<commit_message>
Fix algorithm playback, matrix replay and bounded session state
</commit_message>
<xml_diff>
--- a/smart_campus_navigator/docs/Project_Presentation.pptx
+++ b/smart_campus_navigator/docs/Project_Presentation.pptx
@@ -10672,7 +10672,7 @@
               </a:defRPr>
             </a:pPr>
             <a:r>
-              <a:t>Pseudocode + steps</a:t>
+              <a:t>Fragment-based replay</a:t>
             </a:r>
           </a:p>
           <a:p>
@@ -10688,7 +10688,7 @@
               </a:defRPr>
             </a:pPr>
             <a:r>
-              <a:t>Complexity + measurements</a:t>
+              <a:t>Live comparison matrix</a:t>
             </a:r>
           </a:p>
         </p:txBody>

</xml_diff>